<commit_message>
fix(presentations): 修復 PETsARD 簡報 shadow XML 錯誤 + 版面越界
</commit_message>
<xml_diff>
--- a/public/presentations/petsard-research-20260623.pptx
+++ b/public/presentations/petsard-research-20260623.pptx
@@ -4494,7 +4494,7 @@
         <p:spPr>
           <a:xfrm>
             <a:off x="347472" y="1591056"/>
-            <a:ext cx="1417320" cy="384048"/>
+            <a:ext cx="1417320" cy="347472"/>
           </a:xfrm>
           <a:prstGeom prst="rect">
             <a:avLst/>
@@ -4519,7 +4519,7 @@
         <p:spPr>
           <a:xfrm>
             <a:off x="347472" y="1591056"/>
-            <a:ext cx="1417320" cy="384048"/>
+            <a:ext cx="1417320" cy="347472"/>
           </a:xfrm>
           <a:prstGeom prst="rect">
             <a:avLst/>
@@ -4558,7 +4558,7 @@
         <p:spPr>
           <a:xfrm>
             <a:off x="1764792" y="1591056"/>
-            <a:ext cx="1691640" cy="384048"/>
+            <a:ext cx="1691640" cy="347472"/>
           </a:xfrm>
           <a:prstGeom prst="rect">
             <a:avLst/>
@@ -4583,7 +4583,7 @@
         <p:spPr>
           <a:xfrm>
             <a:off x="1764792" y="1591056"/>
-            <a:ext cx="1691640" cy="384048"/>
+            <a:ext cx="1691640" cy="347472"/>
           </a:xfrm>
           <a:prstGeom prst="rect">
             <a:avLst/>
@@ -4622,7 +4622,7 @@
         <p:spPr>
           <a:xfrm>
             <a:off x="3456432" y="1591056"/>
-            <a:ext cx="1691640" cy="384048"/>
+            <a:ext cx="1691640" cy="347472"/>
           </a:xfrm>
           <a:prstGeom prst="rect">
             <a:avLst/>
@@ -4647,7 +4647,7 @@
         <p:spPr>
           <a:xfrm>
             <a:off x="3456432" y="1591056"/>
-            <a:ext cx="1691640" cy="384048"/>
+            <a:ext cx="1691640" cy="347472"/>
           </a:xfrm>
           <a:prstGeom prst="rect">
             <a:avLst/>
@@ -4686,7 +4686,7 @@
         <p:spPr>
           <a:xfrm>
             <a:off x="5148072" y="1591056"/>
-            <a:ext cx="1691640" cy="384048"/>
+            <a:ext cx="1691640" cy="347472"/>
           </a:xfrm>
           <a:prstGeom prst="rect">
             <a:avLst/>
@@ -4711,7 +4711,7 @@
         <p:spPr>
           <a:xfrm>
             <a:off x="5148072" y="1591056"/>
-            <a:ext cx="1691640" cy="384048"/>
+            <a:ext cx="1691640" cy="347472"/>
           </a:xfrm>
           <a:prstGeom prst="rect">
             <a:avLst/>
@@ -4750,7 +4750,7 @@
         <p:spPr>
           <a:xfrm>
             <a:off x="6839712" y="1591056"/>
-            <a:ext cx="1691640" cy="384048"/>
+            <a:ext cx="1691640" cy="347472"/>
           </a:xfrm>
           <a:prstGeom prst="rect">
             <a:avLst/>
@@ -4775,7 +4775,7 @@
         <p:spPr>
           <a:xfrm>
             <a:off x="6839712" y="1591056"/>
-            <a:ext cx="1691640" cy="384048"/>
+            <a:ext cx="1691640" cy="347472"/>
           </a:xfrm>
           <a:prstGeom prst="rect">
             <a:avLst/>
@@ -4813,8 +4813,8 @@
         </p:nvSpPr>
         <p:spPr>
           <a:xfrm>
-            <a:off x="347472" y="1975104"/>
-            <a:ext cx="1417320" cy="384048"/>
+            <a:off x="347472" y="1938528"/>
+            <a:ext cx="1417320" cy="347472"/>
           </a:xfrm>
           <a:prstGeom prst="rect">
             <a:avLst/>
@@ -4838,8 +4838,8 @@
         </p:nvSpPr>
         <p:spPr>
           <a:xfrm>
-            <a:off x="347472" y="1975104"/>
-            <a:ext cx="1417320" cy="384048"/>
+            <a:off x="347472" y="1938528"/>
+            <a:ext cx="1417320" cy="347472"/>
           </a:xfrm>
           <a:prstGeom prst="rect">
             <a:avLst/>
@@ -4877,8 +4877,8 @@
         </p:nvSpPr>
         <p:spPr>
           <a:xfrm>
-            <a:off x="1764792" y="1975104"/>
-            <a:ext cx="1691640" cy="384048"/>
+            <a:off x="1764792" y="1938528"/>
+            <a:ext cx="1691640" cy="347472"/>
           </a:xfrm>
           <a:prstGeom prst="rect">
             <a:avLst/>
@@ -4902,8 +4902,8 @@
         </p:nvSpPr>
         <p:spPr>
           <a:xfrm>
-            <a:off x="1764792" y="1975104"/>
-            <a:ext cx="1691640" cy="384048"/>
+            <a:off x="1764792" y="1938528"/>
+            <a:ext cx="1691640" cy="347472"/>
           </a:xfrm>
           <a:prstGeom prst="rect">
             <a:avLst/>
@@ -4941,8 +4941,8 @@
         </p:nvSpPr>
         <p:spPr>
           <a:xfrm>
-            <a:off x="3456432" y="1975104"/>
-            <a:ext cx="1691640" cy="384048"/>
+            <a:off x="3456432" y="1938528"/>
+            <a:ext cx="1691640" cy="347472"/>
           </a:xfrm>
           <a:prstGeom prst="rect">
             <a:avLst/>
@@ -4966,8 +4966,8 @@
         </p:nvSpPr>
         <p:spPr>
           <a:xfrm>
-            <a:off x="3456432" y="1975104"/>
-            <a:ext cx="1691640" cy="384048"/>
+            <a:off x="3456432" y="1938528"/>
+            <a:ext cx="1691640" cy="347472"/>
           </a:xfrm>
           <a:prstGeom prst="rect">
             <a:avLst/>
@@ -5005,8 +5005,8 @@
         </p:nvSpPr>
         <p:spPr>
           <a:xfrm>
-            <a:off x="5148072" y="1975104"/>
-            <a:ext cx="1691640" cy="384048"/>
+            <a:off x="5148072" y="1938528"/>
+            <a:ext cx="1691640" cy="347472"/>
           </a:xfrm>
           <a:prstGeom prst="rect">
             <a:avLst/>
@@ -5030,8 +5030,8 @@
         </p:nvSpPr>
         <p:spPr>
           <a:xfrm>
-            <a:off x="5148072" y="1975104"/>
-            <a:ext cx="1691640" cy="384048"/>
+            <a:off x="5148072" y="1938528"/>
+            <a:ext cx="1691640" cy="347472"/>
           </a:xfrm>
           <a:prstGeom prst="rect">
             <a:avLst/>
@@ -5069,8 +5069,8 @@
         </p:nvSpPr>
         <p:spPr>
           <a:xfrm>
-            <a:off x="6839712" y="1975104"/>
-            <a:ext cx="1691640" cy="384048"/>
+            <a:off x="6839712" y="1938528"/>
+            <a:ext cx="1691640" cy="347472"/>
           </a:xfrm>
           <a:prstGeom prst="rect">
             <a:avLst/>
@@ -5094,8 +5094,8 @@
         </p:nvSpPr>
         <p:spPr>
           <a:xfrm>
-            <a:off x="6839712" y="1975104"/>
-            <a:ext cx="1691640" cy="384048"/>
+            <a:off x="6839712" y="1938528"/>
+            <a:ext cx="1691640" cy="347472"/>
           </a:xfrm>
           <a:prstGeom prst="rect">
             <a:avLst/>
@@ -5133,8 +5133,8 @@
         </p:nvSpPr>
         <p:spPr>
           <a:xfrm>
-            <a:off x="347472" y="2359152"/>
-            <a:ext cx="1417320" cy="384048"/>
+            <a:off x="347472" y="2286000"/>
+            <a:ext cx="1417320" cy="347472"/>
           </a:xfrm>
           <a:prstGeom prst="rect">
             <a:avLst/>
@@ -5158,8 +5158,8 @@
         </p:nvSpPr>
         <p:spPr>
           <a:xfrm>
-            <a:off x="347472" y="2359152"/>
-            <a:ext cx="1417320" cy="384048"/>
+            <a:off x="347472" y="2286000"/>
+            <a:ext cx="1417320" cy="347472"/>
           </a:xfrm>
           <a:prstGeom prst="rect">
             <a:avLst/>
@@ -5197,8 +5197,8 @@
         </p:nvSpPr>
         <p:spPr>
           <a:xfrm>
-            <a:off x="1764792" y="2359152"/>
-            <a:ext cx="1691640" cy="384048"/>
+            <a:off x="1764792" y="2286000"/>
+            <a:ext cx="1691640" cy="347472"/>
           </a:xfrm>
           <a:prstGeom prst="rect">
             <a:avLst/>
@@ -5222,8 +5222,8 @@
         </p:nvSpPr>
         <p:spPr>
           <a:xfrm>
-            <a:off x="1764792" y="2359152"/>
-            <a:ext cx="1691640" cy="384048"/>
+            <a:off x="1764792" y="2286000"/>
+            <a:ext cx="1691640" cy="347472"/>
           </a:xfrm>
           <a:prstGeom prst="rect">
             <a:avLst/>
@@ -5261,8 +5261,8 @@
         </p:nvSpPr>
         <p:spPr>
           <a:xfrm>
-            <a:off x="3456432" y="2359152"/>
-            <a:ext cx="1691640" cy="384048"/>
+            <a:off x="3456432" y="2286000"/>
+            <a:ext cx="1691640" cy="347472"/>
           </a:xfrm>
           <a:prstGeom prst="rect">
             <a:avLst/>
@@ -5286,8 +5286,8 @@
         </p:nvSpPr>
         <p:spPr>
           <a:xfrm>
-            <a:off x="3456432" y="2359152"/>
-            <a:ext cx="1691640" cy="384048"/>
+            <a:off x="3456432" y="2286000"/>
+            <a:ext cx="1691640" cy="347472"/>
           </a:xfrm>
           <a:prstGeom prst="rect">
             <a:avLst/>
@@ -5325,8 +5325,8 @@
         </p:nvSpPr>
         <p:spPr>
           <a:xfrm>
-            <a:off x="5148072" y="2359152"/>
-            <a:ext cx="1691640" cy="384048"/>
+            <a:off x="5148072" y="2286000"/>
+            <a:ext cx="1691640" cy="347472"/>
           </a:xfrm>
           <a:prstGeom prst="rect">
             <a:avLst/>
@@ -5350,8 +5350,8 @@
         </p:nvSpPr>
         <p:spPr>
           <a:xfrm>
-            <a:off x="5148072" y="2359152"/>
-            <a:ext cx="1691640" cy="384048"/>
+            <a:off x="5148072" y="2286000"/>
+            <a:ext cx="1691640" cy="347472"/>
           </a:xfrm>
           <a:prstGeom prst="rect">
             <a:avLst/>
@@ -5389,8 +5389,8 @@
         </p:nvSpPr>
         <p:spPr>
           <a:xfrm>
-            <a:off x="6839712" y="2359152"/>
-            <a:ext cx="1691640" cy="384048"/>
+            <a:off x="6839712" y="2286000"/>
+            <a:ext cx="1691640" cy="347472"/>
           </a:xfrm>
           <a:prstGeom prst="rect">
             <a:avLst/>
@@ -5414,8 +5414,8 @@
         </p:nvSpPr>
         <p:spPr>
           <a:xfrm>
-            <a:off x="6839712" y="2359152"/>
-            <a:ext cx="1691640" cy="384048"/>
+            <a:off x="6839712" y="2286000"/>
+            <a:ext cx="1691640" cy="347472"/>
           </a:xfrm>
           <a:prstGeom prst="rect">
             <a:avLst/>
@@ -5453,8 +5453,8 @@
         </p:nvSpPr>
         <p:spPr>
           <a:xfrm>
-            <a:off x="347472" y="2743200"/>
-            <a:ext cx="1417320" cy="384048"/>
+            <a:off x="347472" y="2633472"/>
+            <a:ext cx="1417320" cy="347472"/>
           </a:xfrm>
           <a:prstGeom prst="rect">
             <a:avLst/>
@@ -5478,8 +5478,8 @@
         </p:nvSpPr>
         <p:spPr>
           <a:xfrm>
-            <a:off x="347472" y="2743200"/>
-            <a:ext cx="1417320" cy="384048"/>
+            <a:off x="347472" y="2633472"/>
+            <a:ext cx="1417320" cy="347472"/>
           </a:xfrm>
           <a:prstGeom prst="rect">
             <a:avLst/>
@@ -5517,8 +5517,8 @@
         </p:nvSpPr>
         <p:spPr>
           <a:xfrm>
-            <a:off x="1764792" y="2743200"/>
-            <a:ext cx="1691640" cy="384048"/>
+            <a:off x="1764792" y="2633472"/>
+            <a:ext cx="1691640" cy="347472"/>
           </a:xfrm>
           <a:prstGeom prst="rect">
             <a:avLst/>
@@ -5542,8 +5542,8 @@
         </p:nvSpPr>
         <p:spPr>
           <a:xfrm>
-            <a:off x="1764792" y="2743200"/>
-            <a:ext cx="1691640" cy="384048"/>
+            <a:off x="1764792" y="2633472"/>
+            <a:ext cx="1691640" cy="347472"/>
           </a:xfrm>
           <a:prstGeom prst="rect">
             <a:avLst/>
@@ -5581,8 +5581,8 @@
         </p:nvSpPr>
         <p:spPr>
           <a:xfrm>
-            <a:off x="3456432" y="2743200"/>
-            <a:ext cx="1691640" cy="384048"/>
+            <a:off x="3456432" y="2633472"/>
+            <a:ext cx="1691640" cy="347472"/>
           </a:xfrm>
           <a:prstGeom prst="rect">
             <a:avLst/>
@@ -5606,8 +5606,8 @@
         </p:nvSpPr>
         <p:spPr>
           <a:xfrm>
-            <a:off x="3456432" y="2743200"/>
-            <a:ext cx="1691640" cy="384048"/>
+            <a:off x="3456432" y="2633472"/>
+            <a:ext cx="1691640" cy="347472"/>
           </a:xfrm>
           <a:prstGeom prst="rect">
             <a:avLst/>
@@ -5645,8 +5645,8 @@
         </p:nvSpPr>
         <p:spPr>
           <a:xfrm>
-            <a:off x="5148072" y="2743200"/>
-            <a:ext cx="1691640" cy="384048"/>
+            <a:off x="5148072" y="2633472"/>
+            <a:ext cx="1691640" cy="347472"/>
           </a:xfrm>
           <a:prstGeom prst="rect">
             <a:avLst/>
@@ -5670,8 +5670,8 @@
         </p:nvSpPr>
         <p:spPr>
           <a:xfrm>
-            <a:off x="5148072" y="2743200"/>
-            <a:ext cx="1691640" cy="384048"/>
+            <a:off x="5148072" y="2633472"/>
+            <a:ext cx="1691640" cy="347472"/>
           </a:xfrm>
           <a:prstGeom prst="rect">
             <a:avLst/>
@@ -5709,8 +5709,8 @@
         </p:nvSpPr>
         <p:spPr>
           <a:xfrm>
-            <a:off x="6839712" y="2743200"/>
-            <a:ext cx="1691640" cy="384048"/>
+            <a:off x="6839712" y="2633472"/>
+            <a:ext cx="1691640" cy="347472"/>
           </a:xfrm>
           <a:prstGeom prst="rect">
             <a:avLst/>
@@ -5734,8 +5734,8 @@
         </p:nvSpPr>
         <p:spPr>
           <a:xfrm>
-            <a:off x="6839712" y="2743200"/>
-            <a:ext cx="1691640" cy="384048"/>
+            <a:off x="6839712" y="2633472"/>
+            <a:ext cx="1691640" cy="347472"/>
           </a:xfrm>
           <a:prstGeom prst="rect">
             <a:avLst/>
@@ -5773,8 +5773,8 @@
         </p:nvSpPr>
         <p:spPr>
           <a:xfrm>
-            <a:off x="347472" y="3127248"/>
-            <a:ext cx="1417320" cy="384048"/>
+            <a:off x="347472" y="2980944"/>
+            <a:ext cx="1417320" cy="347472"/>
           </a:xfrm>
           <a:prstGeom prst="rect">
             <a:avLst/>
@@ -5798,8 +5798,8 @@
         </p:nvSpPr>
         <p:spPr>
           <a:xfrm>
-            <a:off x="347472" y="3127248"/>
-            <a:ext cx="1417320" cy="384048"/>
+            <a:off x="347472" y="2980944"/>
+            <a:ext cx="1417320" cy="347472"/>
           </a:xfrm>
           <a:prstGeom prst="rect">
             <a:avLst/>
@@ -5837,8 +5837,8 @@
         </p:nvSpPr>
         <p:spPr>
           <a:xfrm>
-            <a:off x="1764792" y="3127248"/>
-            <a:ext cx="1691640" cy="384048"/>
+            <a:off x="1764792" y="2980944"/>
+            <a:ext cx="1691640" cy="347472"/>
           </a:xfrm>
           <a:prstGeom prst="rect">
             <a:avLst/>
@@ -5862,8 +5862,8 @@
         </p:nvSpPr>
         <p:spPr>
           <a:xfrm>
-            <a:off x="1764792" y="3127248"/>
-            <a:ext cx="1691640" cy="384048"/>
+            <a:off x="1764792" y="2980944"/>
+            <a:ext cx="1691640" cy="347472"/>
           </a:xfrm>
           <a:prstGeom prst="rect">
             <a:avLst/>
@@ -5901,8 +5901,8 @@
         </p:nvSpPr>
         <p:spPr>
           <a:xfrm>
-            <a:off x="3456432" y="3127248"/>
-            <a:ext cx="1691640" cy="384048"/>
+            <a:off x="3456432" y="2980944"/>
+            <a:ext cx="1691640" cy="347472"/>
           </a:xfrm>
           <a:prstGeom prst="rect">
             <a:avLst/>
@@ -5926,8 +5926,8 @@
         </p:nvSpPr>
         <p:spPr>
           <a:xfrm>
-            <a:off x="3456432" y="3127248"/>
-            <a:ext cx="1691640" cy="384048"/>
+            <a:off x="3456432" y="2980944"/>
+            <a:ext cx="1691640" cy="347472"/>
           </a:xfrm>
           <a:prstGeom prst="rect">
             <a:avLst/>
@@ -5965,8 +5965,8 @@
         </p:nvSpPr>
         <p:spPr>
           <a:xfrm>
-            <a:off x="5148072" y="3127248"/>
-            <a:ext cx="1691640" cy="384048"/>
+            <a:off x="5148072" y="2980944"/>
+            <a:ext cx="1691640" cy="347472"/>
           </a:xfrm>
           <a:prstGeom prst="rect">
             <a:avLst/>
@@ -5990,8 +5990,8 @@
         </p:nvSpPr>
         <p:spPr>
           <a:xfrm>
-            <a:off x="5148072" y="3127248"/>
-            <a:ext cx="1691640" cy="384048"/>
+            <a:off x="5148072" y="2980944"/>
+            <a:ext cx="1691640" cy="347472"/>
           </a:xfrm>
           <a:prstGeom prst="rect">
             <a:avLst/>
@@ -6029,8 +6029,8 @@
         </p:nvSpPr>
         <p:spPr>
           <a:xfrm>
-            <a:off x="6839712" y="3127248"/>
-            <a:ext cx="1691640" cy="384048"/>
+            <a:off x="6839712" y="2980944"/>
+            <a:ext cx="1691640" cy="347472"/>
           </a:xfrm>
           <a:prstGeom prst="rect">
             <a:avLst/>
@@ -6054,8 +6054,8 @@
         </p:nvSpPr>
         <p:spPr>
           <a:xfrm>
-            <a:off x="6839712" y="3127248"/>
-            <a:ext cx="1691640" cy="384048"/>
+            <a:off x="6839712" y="2980944"/>
+            <a:ext cx="1691640" cy="347472"/>
           </a:xfrm>
           <a:prstGeom prst="rect">
             <a:avLst/>
@@ -6093,8 +6093,8 @@
         </p:nvSpPr>
         <p:spPr>
           <a:xfrm>
-            <a:off x="347472" y="3511296"/>
-            <a:ext cx="1417320" cy="384048"/>
+            <a:off x="347472" y="3328416"/>
+            <a:ext cx="1417320" cy="347472"/>
           </a:xfrm>
           <a:prstGeom prst="rect">
             <a:avLst/>
@@ -6118,8 +6118,8 @@
         </p:nvSpPr>
         <p:spPr>
           <a:xfrm>
-            <a:off x="347472" y="3511296"/>
-            <a:ext cx="1417320" cy="384048"/>
+            <a:off x="347472" y="3328416"/>
+            <a:ext cx="1417320" cy="347472"/>
           </a:xfrm>
           <a:prstGeom prst="rect">
             <a:avLst/>
@@ -6157,8 +6157,8 @@
         </p:nvSpPr>
         <p:spPr>
           <a:xfrm>
-            <a:off x="1764792" y="3511296"/>
-            <a:ext cx="1691640" cy="384048"/>
+            <a:off x="1764792" y="3328416"/>
+            <a:ext cx="1691640" cy="347472"/>
           </a:xfrm>
           <a:prstGeom prst="rect">
             <a:avLst/>
@@ -6182,8 +6182,8 @@
         </p:nvSpPr>
         <p:spPr>
           <a:xfrm>
-            <a:off x="1764792" y="3511296"/>
-            <a:ext cx="1691640" cy="384048"/>
+            <a:off x="1764792" y="3328416"/>
+            <a:ext cx="1691640" cy="347472"/>
           </a:xfrm>
           <a:prstGeom prst="rect">
             <a:avLst/>
@@ -6221,8 +6221,8 @@
         </p:nvSpPr>
         <p:spPr>
           <a:xfrm>
-            <a:off x="3456432" y="3511296"/>
-            <a:ext cx="1691640" cy="384048"/>
+            <a:off x="3456432" y="3328416"/>
+            <a:ext cx="1691640" cy="347472"/>
           </a:xfrm>
           <a:prstGeom prst="rect">
             <a:avLst/>
@@ -6246,8 +6246,8 @@
         </p:nvSpPr>
         <p:spPr>
           <a:xfrm>
-            <a:off x="3456432" y="3511296"/>
-            <a:ext cx="1691640" cy="384048"/>
+            <a:off x="3456432" y="3328416"/>
+            <a:ext cx="1691640" cy="347472"/>
           </a:xfrm>
           <a:prstGeom prst="rect">
             <a:avLst/>
@@ -6285,8 +6285,8 @@
         </p:nvSpPr>
         <p:spPr>
           <a:xfrm>
-            <a:off x="5148072" y="3511296"/>
-            <a:ext cx="1691640" cy="384048"/>
+            <a:off x="5148072" y="3328416"/>
+            <a:ext cx="1691640" cy="347472"/>
           </a:xfrm>
           <a:prstGeom prst="rect">
             <a:avLst/>
@@ -6310,8 +6310,8 @@
         </p:nvSpPr>
         <p:spPr>
           <a:xfrm>
-            <a:off x="5148072" y="3511296"/>
-            <a:ext cx="1691640" cy="384048"/>
+            <a:off x="5148072" y="3328416"/>
+            <a:ext cx="1691640" cy="347472"/>
           </a:xfrm>
           <a:prstGeom prst="rect">
             <a:avLst/>
@@ -6349,8 +6349,8 @@
         </p:nvSpPr>
         <p:spPr>
           <a:xfrm>
-            <a:off x="6839712" y="3511296"/>
-            <a:ext cx="1691640" cy="384048"/>
+            <a:off x="6839712" y="3328416"/>
+            <a:ext cx="1691640" cy="347472"/>
           </a:xfrm>
           <a:prstGeom prst="rect">
             <a:avLst/>
@@ -6374,8 +6374,8 @@
         </p:nvSpPr>
         <p:spPr>
           <a:xfrm>
-            <a:off x="6839712" y="3511296"/>
-            <a:ext cx="1691640" cy="384048"/>
+            <a:off x="6839712" y="3328416"/>
+            <a:ext cx="1691640" cy="347472"/>
           </a:xfrm>
           <a:prstGeom prst="rect">
             <a:avLst/>
@@ -6413,8 +6413,8 @@
         </p:nvSpPr>
         <p:spPr>
           <a:xfrm>
-            <a:off x="347472" y="3895344"/>
-            <a:ext cx="1417320" cy="384048"/>
+            <a:off x="347472" y="3675888"/>
+            <a:ext cx="1417320" cy="347472"/>
           </a:xfrm>
           <a:prstGeom prst="rect">
             <a:avLst/>
@@ -6438,8 +6438,8 @@
         </p:nvSpPr>
         <p:spPr>
           <a:xfrm>
-            <a:off x="347472" y="3895344"/>
-            <a:ext cx="1417320" cy="384048"/>
+            <a:off x="347472" y="3675888"/>
+            <a:ext cx="1417320" cy="347472"/>
           </a:xfrm>
           <a:prstGeom prst="rect">
             <a:avLst/>
@@ -6477,8 +6477,8 @@
         </p:nvSpPr>
         <p:spPr>
           <a:xfrm>
-            <a:off x="1764792" y="3895344"/>
-            <a:ext cx="1691640" cy="384048"/>
+            <a:off x="1764792" y="3675888"/>
+            <a:ext cx="1691640" cy="347472"/>
           </a:xfrm>
           <a:prstGeom prst="rect">
             <a:avLst/>
@@ -6502,8 +6502,8 @@
         </p:nvSpPr>
         <p:spPr>
           <a:xfrm>
-            <a:off x="1764792" y="3895344"/>
-            <a:ext cx="1691640" cy="384048"/>
+            <a:off x="1764792" y="3675888"/>
+            <a:ext cx="1691640" cy="347472"/>
           </a:xfrm>
           <a:prstGeom prst="rect">
             <a:avLst/>
@@ -6541,8 +6541,8 @@
         </p:nvSpPr>
         <p:spPr>
           <a:xfrm>
-            <a:off x="3456432" y="3895344"/>
-            <a:ext cx="1691640" cy="384048"/>
+            <a:off x="3456432" y="3675888"/>
+            <a:ext cx="1691640" cy="347472"/>
           </a:xfrm>
           <a:prstGeom prst="rect">
             <a:avLst/>
@@ -6566,8 +6566,8 @@
         </p:nvSpPr>
         <p:spPr>
           <a:xfrm>
-            <a:off x="3456432" y="3895344"/>
-            <a:ext cx="1691640" cy="384048"/>
+            <a:off x="3456432" y="3675888"/>
+            <a:ext cx="1691640" cy="347472"/>
           </a:xfrm>
           <a:prstGeom prst="rect">
             <a:avLst/>
@@ -6605,8 +6605,8 @@
         </p:nvSpPr>
         <p:spPr>
           <a:xfrm>
-            <a:off x="5148072" y="3895344"/>
-            <a:ext cx="1691640" cy="384048"/>
+            <a:off x="5148072" y="3675888"/>
+            <a:ext cx="1691640" cy="347472"/>
           </a:xfrm>
           <a:prstGeom prst="rect">
             <a:avLst/>
@@ -6630,8 +6630,8 @@
         </p:nvSpPr>
         <p:spPr>
           <a:xfrm>
-            <a:off x="5148072" y="3895344"/>
-            <a:ext cx="1691640" cy="384048"/>
+            <a:off x="5148072" y="3675888"/>
+            <a:ext cx="1691640" cy="347472"/>
           </a:xfrm>
           <a:prstGeom prst="rect">
             <a:avLst/>
@@ -6669,8 +6669,8 @@
         </p:nvSpPr>
         <p:spPr>
           <a:xfrm>
-            <a:off x="6839712" y="3895344"/>
-            <a:ext cx="1691640" cy="384048"/>
+            <a:off x="6839712" y="3675888"/>
+            <a:ext cx="1691640" cy="347472"/>
           </a:xfrm>
           <a:prstGeom prst="rect">
             <a:avLst/>
@@ -6694,8 +6694,8 @@
         </p:nvSpPr>
         <p:spPr>
           <a:xfrm>
-            <a:off x="6839712" y="3895344"/>
-            <a:ext cx="1691640" cy="384048"/>
+            <a:off x="6839712" y="3675888"/>
+            <a:ext cx="1691640" cy="347472"/>
           </a:xfrm>
           <a:prstGeom prst="rect">
             <a:avLst/>
@@ -6733,8 +6733,8 @@
         </p:nvSpPr>
         <p:spPr>
           <a:xfrm>
-            <a:off x="347472" y="4279392"/>
-            <a:ext cx="1417320" cy="384048"/>
+            <a:off x="347472" y="4023360"/>
+            <a:ext cx="1417320" cy="347472"/>
           </a:xfrm>
           <a:prstGeom prst="rect">
             <a:avLst/>
@@ -6758,8 +6758,8 @@
         </p:nvSpPr>
         <p:spPr>
           <a:xfrm>
-            <a:off x="347472" y="4279392"/>
-            <a:ext cx="1417320" cy="384048"/>
+            <a:off x="347472" y="4023360"/>
+            <a:ext cx="1417320" cy="347472"/>
           </a:xfrm>
           <a:prstGeom prst="rect">
             <a:avLst/>
@@ -6797,8 +6797,8 @@
         </p:nvSpPr>
         <p:spPr>
           <a:xfrm>
-            <a:off x="1764792" y="4279392"/>
-            <a:ext cx="1691640" cy="384048"/>
+            <a:off x="1764792" y="4023360"/>
+            <a:ext cx="1691640" cy="347472"/>
           </a:xfrm>
           <a:prstGeom prst="rect">
             <a:avLst/>
@@ -6822,8 +6822,8 @@
         </p:nvSpPr>
         <p:spPr>
           <a:xfrm>
-            <a:off x="1764792" y="4279392"/>
-            <a:ext cx="1691640" cy="384048"/>
+            <a:off x="1764792" y="4023360"/>
+            <a:ext cx="1691640" cy="347472"/>
           </a:xfrm>
           <a:prstGeom prst="rect">
             <a:avLst/>
@@ -6861,8 +6861,8 @@
         </p:nvSpPr>
         <p:spPr>
           <a:xfrm>
-            <a:off x="3456432" y="4279392"/>
-            <a:ext cx="1691640" cy="384048"/>
+            <a:off x="3456432" y="4023360"/>
+            <a:ext cx="1691640" cy="347472"/>
           </a:xfrm>
           <a:prstGeom prst="rect">
             <a:avLst/>
@@ -6886,8 +6886,8 @@
         </p:nvSpPr>
         <p:spPr>
           <a:xfrm>
-            <a:off x="3456432" y="4279392"/>
-            <a:ext cx="1691640" cy="384048"/>
+            <a:off x="3456432" y="4023360"/>
+            <a:ext cx="1691640" cy="347472"/>
           </a:xfrm>
           <a:prstGeom prst="rect">
             <a:avLst/>
@@ -6925,8 +6925,8 @@
         </p:nvSpPr>
         <p:spPr>
           <a:xfrm>
-            <a:off x="5148072" y="4279392"/>
-            <a:ext cx="1691640" cy="384048"/>
+            <a:off x="5148072" y="4023360"/>
+            <a:ext cx="1691640" cy="347472"/>
           </a:xfrm>
           <a:prstGeom prst="rect">
             <a:avLst/>
@@ -6950,8 +6950,8 @@
         </p:nvSpPr>
         <p:spPr>
           <a:xfrm>
-            <a:off x="5148072" y="4279392"/>
-            <a:ext cx="1691640" cy="384048"/>
+            <a:off x="5148072" y="4023360"/>
+            <a:ext cx="1691640" cy="347472"/>
           </a:xfrm>
           <a:prstGeom prst="rect">
             <a:avLst/>
@@ -6989,8 +6989,8 @@
         </p:nvSpPr>
         <p:spPr>
           <a:xfrm>
-            <a:off x="6839712" y="4279392"/>
-            <a:ext cx="1691640" cy="384048"/>
+            <a:off x="6839712" y="4023360"/>
+            <a:ext cx="1691640" cy="347472"/>
           </a:xfrm>
           <a:prstGeom prst="rect">
             <a:avLst/>
@@ -7014,8 +7014,8 @@
         </p:nvSpPr>
         <p:spPr>
           <a:xfrm>
-            <a:off x="6839712" y="4279392"/>
-            <a:ext cx="1691640" cy="384048"/>
+            <a:off x="6839712" y="4023360"/>
+            <a:ext cx="1691640" cy="347472"/>
           </a:xfrm>
           <a:prstGeom prst="rect">
             <a:avLst/>
@@ -7053,8 +7053,8 @@
         </p:nvSpPr>
         <p:spPr>
           <a:xfrm>
-            <a:off x="347472" y="4663440"/>
-            <a:ext cx="4572000" cy="219456"/>
+            <a:off x="347472" y="4407408"/>
+            <a:ext cx="4572000" cy="274320"/>
           </a:xfrm>
           <a:prstGeom prst="rect">
             <a:avLst/>
@@ -8335,13 +8335,6 @@
             </a:solidFill>
             <a:prstDash val="solid"/>
           </a:ln>
-          <a:effectLst>
-            <a:outerShdw sx="100000" sy="100000" kx="0" ky="0" algn="bl" rotWithShape="0" blurRad="50800" dist="25400" dir="8100000">
-              <a:srgbClr val="000000">
-                <a:alpha val="8000"/>
-              </a:srgbClr>
-            </a:outerShdw>
-          </a:effectLst>
         </p:spPr>
       </p:sp>
       <p:sp>
@@ -8498,13 +8491,6 @@
             </a:solidFill>
             <a:prstDash val="solid"/>
           </a:ln>
-          <a:effectLst>
-            <a:outerShdw sx="100000" sy="100000" kx="0" ky="0" algn="bl" rotWithShape="0" blurRad="50800" dist="25400" dir="8100000">
-              <a:srgbClr val="000000">
-                <a:alpha val="8000"/>
-              </a:srgbClr>
-            </a:outerShdw>
-          </a:effectLst>
         </p:spPr>
       </p:sp>
       <p:sp>
@@ -8661,13 +8647,6 @@
             </a:solidFill>
             <a:prstDash val="solid"/>
           </a:ln>
-          <a:effectLst>
-            <a:outerShdw sx="100000" sy="100000" kx="0" ky="0" algn="bl" rotWithShape="0" blurRad="50800" dist="25400" dir="8100000">
-              <a:srgbClr val="000000">
-                <a:alpha val="8000"/>
-              </a:srgbClr>
-            </a:outerShdw>
-          </a:effectLst>
         </p:spPr>
       </p:sp>
       <p:sp>
@@ -8824,13 +8803,6 @@
             </a:solidFill>
             <a:prstDash val="solid"/>
           </a:ln>
-          <a:effectLst>
-            <a:outerShdw sx="100000" sy="100000" kx="0" ky="0" algn="bl" rotWithShape="0" blurRad="50800" dist="25400" dir="8100000">
-              <a:srgbClr val="000000">
-                <a:alpha val="8000"/>
-              </a:srgbClr>
-            </a:outerShdw>
-          </a:effectLst>
         </p:spPr>
       </p:sp>
       <p:sp>
@@ -8987,13 +8959,6 @@
             </a:solidFill>
             <a:prstDash val="solid"/>
           </a:ln>
-          <a:effectLst>
-            <a:outerShdw sx="100000" sy="100000" kx="0" ky="0" algn="bl" rotWithShape="0" blurRad="50800" dist="25400" dir="8100000">
-              <a:srgbClr val="000000">
-                <a:alpha val="8000"/>
-              </a:srgbClr>
-            </a:outerShdw>
-          </a:effectLst>
         </p:spPr>
       </p:sp>
       <p:sp>
@@ -14005,13 +13970,6 @@
             </a:solidFill>
             <a:prstDash val="solid"/>
           </a:ln>
-          <a:effectLst>
-            <a:outerShdw sx="100000" sy="100000" kx="0" ky="0" algn="bl" rotWithShape="0" blurRad="50800" dist="25400" dir="8100000">
-              <a:srgbClr val="000000">
-                <a:alpha val="8000"/>
-              </a:srgbClr>
-            </a:outerShdw>
-          </a:effectLst>
         </p:spPr>
       </p:sp>
       <p:sp>
@@ -14168,13 +14126,6 @@
             </a:solidFill>
             <a:prstDash val="solid"/>
           </a:ln>
-          <a:effectLst>
-            <a:outerShdw sx="100000" sy="100000" kx="0" ky="0" algn="bl" rotWithShape="0" blurRad="50800" dist="25400" dir="8100000">
-              <a:srgbClr val="000000">
-                <a:alpha val="8000"/>
-              </a:srgbClr>
-            </a:outerShdw>
-          </a:effectLst>
         </p:spPr>
       </p:sp>
       <p:sp>
@@ -14331,13 +14282,6 @@
             </a:solidFill>
             <a:prstDash val="solid"/>
           </a:ln>
-          <a:effectLst>
-            <a:outerShdw sx="100000" sy="100000" kx="0" ky="0" algn="bl" rotWithShape="0" blurRad="50800" dist="25400" dir="8100000">
-              <a:srgbClr val="000000">
-                <a:alpha val="8000"/>
-              </a:srgbClr>
-            </a:outerShdw>
-          </a:effectLst>
         </p:spPr>
       </p:sp>
       <p:sp>
@@ -17894,13 +17838,6 @@
             </a:solidFill>
             <a:prstDash val="solid"/>
           </a:ln>
-          <a:effectLst>
-            <a:outerShdw sx="100000" sy="100000" kx="0" ky="0" algn="bl" rotWithShape="0" blurRad="63500" dist="25400" dir="8100000">
-              <a:srgbClr val="000000">
-                <a:alpha val="10000"/>
-              </a:srgbClr>
-            </a:outerShdw>
-          </a:effectLst>
         </p:spPr>
       </p:sp>
       <p:sp>
@@ -18150,13 +18087,6 @@
             </a:solidFill>
             <a:prstDash val="solid"/>
           </a:ln>
-          <a:effectLst>
-            <a:outerShdw sx="100000" sy="100000" kx="0" ky="0" algn="bl" rotWithShape="0" blurRad="63500" dist="25400" dir="8100000">
-              <a:srgbClr val="000000">
-                <a:alpha val="10000"/>
-              </a:srgbClr>
-            </a:outerShdw>
-          </a:effectLst>
         </p:spPr>
       </p:sp>
       <p:sp>
@@ -21892,8 +21822,8 @@
         </p:nvSpPr>
         <p:spPr>
           <a:xfrm>
-            <a:off x="457200" y="4572000"/>
-            <a:ext cx="8229600" cy="137160"/>
+            <a:off x="457200" y="4434840"/>
+            <a:ext cx="8229600" cy="274320"/>
           </a:xfrm>
           <a:prstGeom prst="rect">
             <a:avLst/>

</xml_diff>